<commit_message>
updated screenshots and documents
</commit_message>
<xml_diff>
--- a/docs/Task_Manager_Back4App_Presentation.pptx
+++ b/docs/Task_Manager_Back4App_Presentation.pptx
@@ -5,17 +5,18 @@
     <p:sldMasterId id="2147483648" r:id="rId1"/>
   </p:sldMasterIdLst>
   <p:sldIdLst>
-    <p:sldId id="256" r:id="rId7"/>
-    <p:sldId id="257" r:id="rId8"/>
-    <p:sldId id="258" r:id="rId9"/>
-    <p:sldId id="259" r:id="rId10"/>
-    <p:sldId id="260" r:id="rId11"/>
-    <p:sldId id="261" r:id="rId12"/>
-    <p:sldId id="262" r:id="rId13"/>
-    <p:sldId id="263" r:id="rId14"/>
-    <p:sldId id="264" r:id="rId15"/>
+    <p:sldId id="256" r:id="rId2"/>
+    <p:sldId id="257" r:id="rId3"/>
+    <p:sldId id="258" r:id="rId4"/>
+    <p:sldId id="259" r:id="rId5"/>
+    <p:sldId id="265" r:id="rId6"/>
+    <p:sldId id="260" r:id="rId7"/>
+    <p:sldId id="261" r:id="rId8"/>
+    <p:sldId id="262" r:id="rId9"/>
+    <p:sldId id="263" r:id="rId10"/>
+    <p:sldId id="264" r:id="rId11"/>
   </p:sldIdLst>
-  <p:sldSz cx="12191695" cy="6858000" type="screen4x3"/>
+  <p:sldSz cx="12192000" cy="6858000"/>
   <p:notesSz cx="6858000" cy="9144000"/>
   <p:defaultTextStyle>
     <a:defPPr>
@@ -112,6 +113,22 @@
       </a:defRPr>
     </a:lvl9pPr>
   </p:defaultTextStyle>
+  <p:extLst>
+    <p:ext uri="{EFAFB233-063F-42B5-8137-9DF3F51BA10A}">
+      <p15:sldGuideLst xmlns:p15="http://schemas.microsoft.com/office/powerpoint/2012/main">
+        <p15:guide id="1" orient="horz" pos="2160">
+          <p15:clr>
+            <a:srgbClr val="A4A3A4"/>
+          </p15:clr>
+        </p15:guide>
+        <p15:guide id="2" pos="2880">
+          <p15:clr>
+            <a:srgbClr val="A4A3A4"/>
+          </p15:clr>
+        </p15:guide>
+      </p15:sldGuideLst>
+    </p:ext>
+  </p:extLst>
 </p:presentation>
 </file>
 
@@ -153,10 +170,9 @@
           <a:lstStyle/>
           <a:p>
             <a:r>
-              <a:rPr lang="en-US" smtClean="0"/>
+              <a:rPr lang="en-US"/>
               <a:t>Click to edit Master title style</a:t>
             </a:r>
-            <a:endParaRPr lang="en-US"/>
           </a:p>
         </p:txBody>
       </p:sp>
@@ -272,10 +288,9 @@
           </a:lstStyle>
           <a:p>
             <a:r>
-              <a:rPr lang="en-US" smtClean="0"/>
+              <a:rPr lang="en-US"/>
               <a:t>Click to edit Master subtitle style</a:t>
             </a:r>
-            <a:endParaRPr lang="en-US"/>
           </a:p>
         </p:txBody>
       </p:sp>
@@ -296,7 +311,7 @@
           <a:p>
             <a:fld id="{5BCAD085-E8A6-8845-BD4E-CB4CCA059FC4}" type="datetimeFigureOut">
               <a:rPr lang="en-US" smtClean="0"/>
-              <a:t>1/27/13</a:t>
+              <a:t>4/29/2026</a:t>
             </a:fld>
             <a:endParaRPr lang="en-US"/>
           </a:p>
@@ -390,10 +405,9 @@
           <a:lstStyle/>
           <a:p>
             <a:r>
-              <a:rPr lang="en-US" smtClean="0"/>
+              <a:rPr lang="en-US"/>
               <a:t>Click to edit Master title style</a:t>
             </a:r>
-            <a:endParaRPr lang="en-US"/>
           </a:p>
         </p:txBody>
       </p:sp>
@@ -414,38 +428,37 @@
           <a:p>
             <a:pPr lvl="0"/>
             <a:r>
-              <a:rPr lang="en-US" smtClean="0"/>
+              <a:rPr lang="en-US"/>
               <a:t>Click to edit Master text styles</a:t>
             </a:r>
           </a:p>
           <a:p>
             <a:pPr lvl="1"/>
             <a:r>
-              <a:rPr lang="en-US" smtClean="0"/>
+              <a:rPr lang="en-US"/>
               <a:t>Second level</a:t>
             </a:r>
           </a:p>
           <a:p>
             <a:pPr lvl="2"/>
             <a:r>
-              <a:rPr lang="en-US" smtClean="0"/>
+              <a:rPr lang="en-US"/>
               <a:t>Third level</a:t>
             </a:r>
           </a:p>
           <a:p>
             <a:pPr lvl="3"/>
             <a:r>
-              <a:rPr lang="en-US" smtClean="0"/>
+              <a:rPr lang="en-US"/>
               <a:t>Fourth level</a:t>
             </a:r>
           </a:p>
           <a:p>
             <a:pPr lvl="4"/>
             <a:r>
-              <a:rPr lang="en-US" smtClean="0"/>
+              <a:rPr lang="en-US"/>
               <a:t>Fifth level</a:t>
             </a:r>
-            <a:endParaRPr lang="en-US"/>
           </a:p>
         </p:txBody>
       </p:sp>
@@ -466,7 +479,7 @@
           <a:p>
             <a:fld id="{5BCAD085-E8A6-8845-BD4E-CB4CCA059FC4}" type="datetimeFigureOut">
               <a:rPr lang="en-US" smtClean="0"/>
-              <a:t>1/27/13</a:t>
+              <a:t>4/29/2026</a:t>
             </a:fld>
             <a:endParaRPr lang="en-US"/>
           </a:p>
@@ -565,10 +578,9 @@
           <a:lstStyle/>
           <a:p>
             <a:r>
-              <a:rPr lang="en-US" smtClean="0"/>
+              <a:rPr lang="en-US"/>
               <a:t>Click to edit Master title style</a:t>
             </a:r>
-            <a:endParaRPr lang="en-US"/>
           </a:p>
         </p:txBody>
       </p:sp>
@@ -594,38 +606,37 @@
           <a:p>
             <a:pPr lvl="0"/>
             <a:r>
-              <a:rPr lang="en-US" smtClean="0"/>
+              <a:rPr lang="en-US"/>
               <a:t>Click to edit Master text styles</a:t>
             </a:r>
           </a:p>
           <a:p>
             <a:pPr lvl="1"/>
             <a:r>
-              <a:rPr lang="en-US" smtClean="0"/>
+              <a:rPr lang="en-US"/>
               <a:t>Second level</a:t>
             </a:r>
           </a:p>
           <a:p>
             <a:pPr lvl="2"/>
             <a:r>
-              <a:rPr lang="en-US" smtClean="0"/>
+              <a:rPr lang="en-US"/>
               <a:t>Third level</a:t>
             </a:r>
           </a:p>
           <a:p>
             <a:pPr lvl="3"/>
             <a:r>
-              <a:rPr lang="en-US" smtClean="0"/>
+              <a:rPr lang="en-US"/>
               <a:t>Fourth level</a:t>
             </a:r>
           </a:p>
           <a:p>
             <a:pPr lvl="4"/>
             <a:r>
-              <a:rPr lang="en-US" smtClean="0"/>
+              <a:rPr lang="en-US"/>
               <a:t>Fifth level</a:t>
             </a:r>
-            <a:endParaRPr lang="en-US"/>
           </a:p>
         </p:txBody>
       </p:sp>
@@ -646,7 +657,7 @@
           <a:p>
             <a:fld id="{5BCAD085-E8A6-8845-BD4E-CB4CCA059FC4}" type="datetimeFigureOut">
               <a:rPr lang="en-US" smtClean="0"/>
-              <a:t>1/27/13</a:t>
+              <a:t>4/29/2026</a:t>
             </a:fld>
             <a:endParaRPr lang="en-US"/>
           </a:p>
@@ -740,10 +751,9 @@
           <a:lstStyle/>
           <a:p>
             <a:r>
-              <a:rPr lang="en-US" smtClean="0"/>
+              <a:rPr lang="en-US"/>
               <a:t>Click to edit Master title style</a:t>
             </a:r>
-            <a:endParaRPr lang="en-US"/>
           </a:p>
         </p:txBody>
       </p:sp>
@@ -764,38 +774,37 @@
           <a:p>
             <a:pPr lvl="0"/>
             <a:r>
-              <a:rPr lang="en-US" smtClean="0"/>
+              <a:rPr lang="en-US"/>
               <a:t>Click to edit Master text styles</a:t>
             </a:r>
           </a:p>
           <a:p>
             <a:pPr lvl="1"/>
             <a:r>
-              <a:rPr lang="en-US" smtClean="0"/>
+              <a:rPr lang="en-US"/>
               <a:t>Second level</a:t>
             </a:r>
           </a:p>
           <a:p>
             <a:pPr lvl="2"/>
             <a:r>
-              <a:rPr lang="en-US" smtClean="0"/>
+              <a:rPr lang="en-US"/>
               <a:t>Third level</a:t>
             </a:r>
           </a:p>
           <a:p>
             <a:pPr lvl="3"/>
             <a:r>
-              <a:rPr lang="en-US" smtClean="0"/>
+              <a:rPr lang="en-US"/>
               <a:t>Fourth level</a:t>
             </a:r>
           </a:p>
           <a:p>
             <a:pPr lvl="4"/>
             <a:r>
-              <a:rPr lang="en-US" smtClean="0"/>
+              <a:rPr lang="en-US"/>
               <a:t>Fifth level</a:t>
             </a:r>
-            <a:endParaRPr lang="en-US"/>
           </a:p>
         </p:txBody>
       </p:sp>
@@ -816,7 +825,7 @@
           <a:p>
             <a:fld id="{5BCAD085-E8A6-8845-BD4E-CB4CCA059FC4}" type="datetimeFigureOut">
               <a:rPr lang="en-US" smtClean="0"/>
-              <a:t>1/27/13</a:t>
+              <a:t>4/29/2026</a:t>
             </a:fld>
             <a:endParaRPr lang="en-US"/>
           </a:p>
@@ -919,10 +928,9 @@
           </a:lstStyle>
           <a:p>
             <a:r>
-              <a:rPr lang="en-US" smtClean="0"/>
+              <a:rPr lang="en-US"/>
               <a:t>Click to edit Master title style</a:t>
             </a:r>
-            <a:endParaRPr lang="en-US"/>
           </a:p>
         </p:txBody>
       </p:sp>
@@ -1039,7 +1047,7 @@
           <a:p>
             <a:pPr lvl="0"/>
             <a:r>
-              <a:rPr lang="en-US" smtClean="0"/>
+              <a:rPr lang="en-US"/>
               <a:t>Click to edit Master text styles</a:t>
             </a:r>
           </a:p>
@@ -1062,7 +1070,7 @@
           <a:p>
             <a:fld id="{5BCAD085-E8A6-8845-BD4E-CB4CCA059FC4}" type="datetimeFigureOut">
               <a:rPr lang="en-US" smtClean="0"/>
-              <a:t>1/27/13</a:t>
+              <a:t>4/29/2026</a:t>
             </a:fld>
             <a:endParaRPr lang="en-US"/>
           </a:p>
@@ -1156,10 +1164,9 @@
           <a:lstStyle/>
           <a:p>
             <a:r>
-              <a:rPr lang="en-US" smtClean="0"/>
+              <a:rPr lang="en-US"/>
               <a:t>Click to edit Master title style</a:t>
             </a:r>
-            <a:endParaRPr lang="en-US"/>
           </a:p>
         </p:txBody>
       </p:sp>
@@ -1213,38 +1220,37 @@
           <a:p>
             <a:pPr lvl="0"/>
             <a:r>
-              <a:rPr lang="en-US" smtClean="0"/>
+              <a:rPr lang="en-US"/>
               <a:t>Click to edit Master text styles</a:t>
             </a:r>
           </a:p>
           <a:p>
             <a:pPr lvl="1"/>
             <a:r>
-              <a:rPr lang="en-US" smtClean="0"/>
+              <a:rPr lang="en-US"/>
               <a:t>Second level</a:t>
             </a:r>
           </a:p>
           <a:p>
             <a:pPr lvl="2"/>
             <a:r>
-              <a:rPr lang="en-US" smtClean="0"/>
+              <a:rPr lang="en-US"/>
               <a:t>Third level</a:t>
             </a:r>
           </a:p>
           <a:p>
             <a:pPr lvl="3"/>
             <a:r>
-              <a:rPr lang="en-US" smtClean="0"/>
+              <a:rPr lang="en-US"/>
               <a:t>Fourth level</a:t>
             </a:r>
           </a:p>
           <a:p>
             <a:pPr lvl="4"/>
             <a:r>
-              <a:rPr lang="en-US" smtClean="0"/>
+              <a:rPr lang="en-US"/>
               <a:t>Fifth level</a:t>
             </a:r>
-            <a:endParaRPr lang="en-US"/>
           </a:p>
         </p:txBody>
       </p:sp>
@@ -1298,38 +1304,37 @@
           <a:p>
             <a:pPr lvl="0"/>
             <a:r>
-              <a:rPr lang="en-US" smtClean="0"/>
+              <a:rPr lang="en-US"/>
               <a:t>Click to edit Master text styles</a:t>
             </a:r>
           </a:p>
           <a:p>
             <a:pPr lvl="1"/>
             <a:r>
-              <a:rPr lang="en-US" smtClean="0"/>
+              <a:rPr lang="en-US"/>
               <a:t>Second level</a:t>
             </a:r>
           </a:p>
           <a:p>
             <a:pPr lvl="2"/>
             <a:r>
-              <a:rPr lang="en-US" smtClean="0"/>
+              <a:rPr lang="en-US"/>
               <a:t>Third level</a:t>
             </a:r>
           </a:p>
           <a:p>
             <a:pPr lvl="3"/>
             <a:r>
-              <a:rPr lang="en-US" smtClean="0"/>
+              <a:rPr lang="en-US"/>
               <a:t>Fourth level</a:t>
             </a:r>
           </a:p>
           <a:p>
             <a:pPr lvl="4"/>
             <a:r>
-              <a:rPr lang="en-US" smtClean="0"/>
+              <a:rPr lang="en-US"/>
               <a:t>Fifth level</a:t>
             </a:r>
-            <a:endParaRPr lang="en-US"/>
           </a:p>
         </p:txBody>
       </p:sp>
@@ -1350,7 +1355,7 @@
           <a:p>
             <a:fld id="{5BCAD085-E8A6-8845-BD4E-CB4CCA059FC4}" type="datetimeFigureOut">
               <a:rPr lang="en-US" smtClean="0"/>
-              <a:t>1/27/13</a:t>
+              <a:t>4/29/2026</a:t>
             </a:fld>
             <a:endParaRPr lang="en-US"/>
           </a:p>
@@ -1448,10 +1453,9 @@
           </a:lstStyle>
           <a:p>
             <a:r>
-              <a:rPr lang="en-US" smtClean="0"/>
+              <a:rPr lang="en-US"/>
               <a:t>Click to edit Master title style</a:t>
             </a:r>
-            <a:endParaRPr lang="en-US"/>
           </a:p>
         </p:txBody>
       </p:sp>
@@ -1514,7 +1518,7 @@
           <a:p>
             <a:pPr lvl="0"/>
             <a:r>
-              <a:rPr lang="en-US" smtClean="0"/>
+              <a:rPr lang="en-US"/>
               <a:t>Click to edit Master text styles</a:t>
             </a:r>
           </a:p>
@@ -1570,38 +1574,37 @@
           <a:p>
             <a:pPr lvl="0"/>
             <a:r>
-              <a:rPr lang="en-US" smtClean="0"/>
+              <a:rPr lang="en-US"/>
               <a:t>Click to edit Master text styles</a:t>
             </a:r>
           </a:p>
           <a:p>
             <a:pPr lvl="1"/>
             <a:r>
-              <a:rPr lang="en-US" smtClean="0"/>
+              <a:rPr lang="en-US"/>
               <a:t>Second level</a:t>
             </a:r>
           </a:p>
           <a:p>
             <a:pPr lvl="2"/>
             <a:r>
-              <a:rPr lang="en-US" smtClean="0"/>
+              <a:rPr lang="en-US"/>
               <a:t>Third level</a:t>
             </a:r>
           </a:p>
           <a:p>
             <a:pPr lvl="3"/>
             <a:r>
-              <a:rPr lang="en-US" smtClean="0"/>
+              <a:rPr lang="en-US"/>
               <a:t>Fourth level</a:t>
             </a:r>
           </a:p>
           <a:p>
             <a:pPr lvl="4"/>
             <a:r>
-              <a:rPr lang="en-US" smtClean="0"/>
+              <a:rPr lang="en-US"/>
               <a:t>Fifth level</a:t>
             </a:r>
-            <a:endParaRPr lang="en-US"/>
           </a:p>
         </p:txBody>
       </p:sp>
@@ -1664,7 +1667,7 @@
           <a:p>
             <a:pPr lvl="0"/>
             <a:r>
-              <a:rPr lang="en-US" smtClean="0"/>
+              <a:rPr lang="en-US"/>
               <a:t>Click to edit Master text styles</a:t>
             </a:r>
           </a:p>
@@ -1720,38 +1723,37 @@
           <a:p>
             <a:pPr lvl="0"/>
             <a:r>
-              <a:rPr lang="en-US" smtClean="0"/>
+              <a:rPr lang="en-US"/>
               <a:t>Click to edit Master text styles</a:t>
             </a:r>
           </a:p>
           <a:p>
             <a:pPr lvl="1"/>
             <a:r>
-              <a:rPr lang="en-US" smtClean="0"/>
+              <a:rPr lang="en-US"/>
               <a:t>Second level</a:t>
             </a:r>
           </a:p>
           <a:p>
             <a:pPr lvl="2"/>
             <a:r>
-              <a:rPr lang="en-US" smtClean="0"/>
+              <a:rPr lang="en-US"/>
               <a:t>Third level</a:t>
             </a:r>
           </a:p>
           <a:p>
             <a:pPr lvl="3"/>
             <a:r>
-              <a:rPr lang="en-US" smtClean="0"/>
+              <a:rPr lang="en-US"/>
               <a:t>Fourth level</a:t>
             </a:r>
           </a:p>
           <a:p>
             <a:pPr lvl="4"/>
             <a:r>
-              <a:rPr lang="en-US" smtClean="0"/>
+              <a:rPr lang="en-US"/>
               <a:t>Fifth level</a:t>
             </a:r>
-            <a:endParaRPr lang="en-US"/>
           </a:p>
         </p:txBody>
       </p:sp>
@@ -1772,7 +1774,7 @@
           <a:p>
             <a:fld id="{5BCAD085-E8A6-8845-BD4E-CB4CCA059FC4}" type="datetimeFigureOut">
               <a:rPr lang="en-US" smtClean="0"/>
-              <a:t>1/27/13</a:t>
+              <a:t>4/29/2026</a:t>
             </a:fld>
             <a:endParaRPr lang="en-US"/>
           </a:p>
@@ -1866,10 +1868,9 @@
           <a:lstStyle/>
           <a:p>
             <a:r>
-              <a:rPr lang="en-US" smtClean="0"/>
+              <a:rPr lang="en-US"/>
               <a:t>Click to edit Master title style</a:t>
             </a:r>
-            <a:endParaRPr lang="en-US"/>
           </a:p>
         </p:txBody>
       </p:sp>
@@ -1890,7 +1891,7 @@
           <a:p>
             <a:fld id="{5BCAD085-E8A6-8845-BD4E-CB4CCA059FC4}" type="datetimeFigureOut">
               <a:rPr lang="en-US" smtClean="0"/>
-              <a:t>1/27/13</a:t>
+              <a:t>4/29/2026</a:t>
             </a:fld>
             <a:endParaRPr lang="en-US"/>
           </a:p>
@@ -1985,7 +1986,7 @@
           <a:p>
             <a:fld id="{5BCAD085-E8A6-8845-BD4E-CB4CCA059FC4}" type="datetimeFigureOut">
               <a:rPr lang="en-US" smtClean="0"/>
-              <a:t>1/27/13</a:t>
+              <a:t>4/29/2026</a:t>
             </a:fld>
             <a:endParaRPr lang="en-US"/>
           </a:p>
@@ -2088,10 +2089,9 @@
           </a:lstStyle>
           <a:p>
             <a:r>
-              <a:rPr lang="en-US" smtClean="0"/>
+              <a:rPr lang="en-US"/>
               <a:t>Click to edit Master title style</a:t>
             </a:r>
-            <a:endParaRPr lang="en-US"/>
           </a:p>
         </p:txBody>
       </p:sp>
@@ -2145,38 +2145,37 @@
           <a:p>
             <a:pPr lvl="0"/>
             <a:r>
-              <a:rPr lang="en-US" smtClean="0"/>
+              <a:rPr lang="en-US"/>
               <a:t>Click to edit Master text styles</a:t>
             </a:r>
           </a:p>
           <a:p>
             <a:pPr lvl="1"/>
             <a:r>
-              <a:rPr lang="en-US" smtClean="0"/>
+              <a:rPr lang="en-US"/>
               <a:t>Second level</a:t>
             </a:r>
           </a:p>
           <a:p>
             <a:pPr lvl="2"/>
             <a:r>
-              <a:rPr lang="en-US" smtClean="0"/>
+              <a:rPr lang="en-US"/>
               <a:t>Third level</a:t>
             </a:r>
           </a:p>
           <a:p>
             <a:pPr lvl="3"/>
             <a:r>
-              <a:rPr lang="en-US" smtClean="0"/>
+              <a:rPr lang="en-US"/>
               <a:t>Fourth level</a:t>
             </a:r>
           </a:p>
           <a:p>
             <a:pPr lvl="4"/>
             <a:r>
-              <a:rPr lang="en-US" smtClean="0"/>
+              <a:rPr lang="en-US"/>
               <a:t>Fifth level</a:t>
             </a:r>
-            <a:endParaRPr lang="en-US"/>
           </a:p>
         </p:txBody>
       </p:sp>
@@ -2239,7 +2238,7 @@
           <a:p>
             <a:pPr lvl="0"/>
             <a:r>
-              <a:rPr lang="en-US" smtClean="0"/>
+              <a:rPr lang="en-US"/>
               <a:t>Click to edit Master text styles</a:t>
             </a:r>
           </a:p>
@@ -2262,7 +2261,7 @@
           <a:p>
             <a:fld id="{5BCAD085-E8A6-8845-BD4E-CB4CCA059FC4}" type="datetimeFigureOut">
               <a:rPr lang="en-US" smtClean="0"/>
-              <a:t>1/27/13</a:t>
+              <a:t>4/29/2026</a:t>
             </a:fld>
             <a:endParaRPr lang="en-US"/>
           </a:p>
@@ -2365,10 +2364,9 @@
           </a:lstStyle>
           <a:p>
             <a:r>
-              <a:rPr lang="en-US" smtClean="0"/>
+              <a:rPr lang="en-US"/>
               <a:t>Click to edit Master title style</a:t>
             </a:r>
-            <a:endParaRPr lang="en-US"/>
           </a:p>
         </p:txBody>
       </p:sp>
@@ -2492,7 +2490,7 @@
           <a:p>
             <a:pPr lvl="0"/>
             <a:r>
-              <a:rPr lang="en-US" smtClean="0"/>
+              <a:rPr lang="en-US"/>
               <a:t>Click to edit Master text styles</a:t>
             </a:r>
           </a:p>
@@ -2515,7 +2513,7 @@
           <a:p>
             <a:fld id="{5BCAD085-E8A6-8845-BD4E-CB4CCA059FC4}" type="datetimeFigureOut">
               <a:rPr lang="en-US" smtClean="0"/>
-              <a:t>1/27/13</a:t>
+              <a:t>4/29/2026</a:t>
             </a:fld>
             <a:endParaRPr lang="en-US"/>
           </a:p>
@@ -2624,10 +2622,9 @@
           <a:lstStyle/>
           <a:p>
             <a:r>
-              <a:rPr lang="en-US" smtClean="0"/>
+              <a:rPr lang="en-US"/>
               <a:t>Click to edit Master title style</a:t>
             </a:r>
-            <a:endParaRPr lang="en-US"/>
           </a:p>
         </p:txBody>
       </p:sp>
@@ -2658,38 +2655,37 @@
           <a:p>
             <a:pPr lvl="0"/>
             <a:r>
-              <a:rPr lang="en-US" smtClean="0"/>
+              <a:rPr lang="en-US"/>
               <a:t>Click to edit Master text styles</a:t>
             </a:r>
           </a:p>
           <a:p>
             <a:pPr lvl="1"/>
             <a:r>
-              <a:rPr lang="en-US" smtClean="0"/>
+              <a:rPr lang="en-US"/>
               <a:t>Second level</a:t>
             </a:r>
           </a:p>
           <a:p>
             <a:pPr lvl="2"/>
             <a:r>
-              <a:rPr lang="en-US" smtClean="0"/>
+              <a:rPr lang="en-US"/>
               <a:t>Third level</a:t>
             </a:r>
           </a:p>
           <a:p>
             <a:pPr lvl="3"/>
             <a:r>
-              <a:rPr lang="en-US" smtClean="0"/>
+              <a:rPr lang="en-US"/>
               <a:t>Fourth level</a:t>
             </a:r>
           </a:p>
           <a:p>
             <a:pPr lvl="4"/>
             <a:r>
-              <a:rPr lang="en-US" smtClean="0"/>
+              <a:rPr lang="en-US"/>
               <a:t>Fifth level</a:t>
             </a:r>
-            <a:endParaRPr lang="en-US"/>
           </a:p>
         </p:txBody>
       </p:sp>
@@ -2728,7 +2724,7 @@
           <a:p>
             <a:fld id="{5BCAD085-E8A6-8845-BD4E-CB4CCA059FC4}" type="datetimeFigureOut">
               <a:rPr lang="en-US" smtClean="0"/>
-              <a:t>1/27/13</a:t>
+              <a:t>4/29/2026</a:t>
             </a:fld>
             <a:endParaRPr lang="en-US"/>
           </a:p>
@@ -3087,7 +3083,7 @@
 </file>
 
 <file path=ppt/slides/slide1.xml><?xml version="1.0" encoding="utf-8"?>
-<p:sld xmlns:a="http://schemas.openxmlformats.org/drawingml/2006/main" xmlns:p="http://schemas.openxmlformats.org/presentationml/2006/main" xmlns:r="http://schemas.openxmlformats.org/officeDocument/2006/relationships">
+<p:sld xmlns:a="http://schemas.openxmlformats.org/drawingml/2006/main" xmlns:r="http://schemas.openxmlformats.org/officeDocument/2006/relationships" xmlns:p="http://schemas.openxmlformats.org/presentationml/2006/main">
   <p:cSld>
     <p:bg>
       <p:bgPr>
@@ -3103,7 +3099,14 @@
         <p:cNvGrpSpPr/>
         <p:nvPr/>
       </p:nvGrpSpPr>
-      <p:grpSpPr/>
+      <p:grpSpPr>
+        <a:xfrm>
+          <a:off x="0" y="0"/>
+          <a:ext cx="0" cy="0"/>
+          <a:chOff x="0" y="0"/>
+          <a:chExt cx="0" cy="0"/>
+        </a:xfrm>
+      </p:grpSpPr>
       <p:sp>
         <p:nvSpPr>
           <p:cNvPr id="2" name="TextBox 1"/>
@@ -3127,7 +3130,7 @@
           <a:lstStyle/>
           <a:p>
             <a:pPr>
-              <a:defRPr b="1" sz="3400">
+              <a:defRPr sz="3400" b="1">
                 <a:solidFill>
                   <a:srgbClr val="1F2925"/>
                 </a:solidFill>
@@ -3182,7 +3185,7 @@
         </p:nvSpPr>
         <p:spPr>
           <a:xfrm>
-            <a:off x="731520" y="1828800"/>
+            <a:off x="713232" y="1576873"/>
             <a:ext cx="10698480" cy="3291840"/>
           </a:xfrm>
           <a:prstGeom prst="rect">
@@ -3212,7 +3215,7 @@
           </a:fontRef>
         </p:style>
         <p:txBody>
-          <a:bodyPr rtlCol="0" anchor="ctr" lIns="320040" tIns="256032"/>
+          <a:bodyPr lIns="320040" tIns="256032" rtlCol="0" anchor="ctr"/>
           <a:lstStyle/>
           <a:p>
             <a:pPr algn="ctr">
@@ -3223,6 +3226,7 @@
               </a:defRPr>
             </a:pPr>
             <a:r>
+              <a:rPr dirty="0"/>
               <a:t>Student task management with authentication, cloud storage, dynamic syncing, and secure logout.</a:t>
             </a:r>
           </a:p>
@@ -3235,7 +3239,259 @@
               </a:defRPr>
             </a:pPr>
             <a:r>
-              <a:t>Frontend: Flutter | Backend: Back4App Parse Server | Database: Back4App Cloud Database</a:t>
+              <a:rPr dirty="0"/>
+              <a:t>Frontend: Flutter | Backend: </a:t>
+            </a:r>
+            <a:r>
+              <a:rPr dirty="0" err="1"/>
+              <a:t>Back4App</a:t>
+            </a:r>
+            <a:r>
+              <a:rPr dirty="0"/>
+              <a:t> Parse Server | Database: </a:t>
+            </a:r>
+            <a:r>
+              <a:rPr dirty="0" err="1"/>
+              <a:t>Back4App</a:t>
+            </a:r>
+            <a:r>
+              <a:rPr dirty="0"/>
+              <a:t> Cloud Database</a:t>
+            </a:r>
+            <a:endParaRPr lang="en-US" dirty="0"/>
+          </a:p>
+          <a:p>
+            <a:pPr>
+              <a:defRPr sz="1800">
+                <a:solidFill>
+                  <a:srgbClr val="52615B"/>
+                </a:solidFill>
+              </a:defRPr>
+            </a:pPr>
+            <a:endParaRPr lang="en-US" dirty="0"/>
+          </a:p>
+          <a:p>
+            <a:pPr>
+              <a:defRPr sz="1800">
+                <a:solidFill>
+                  <a:srgbClr val="52615B"/>
+                </a:solidFill>
+              </a:defRPr>
+            </a:pPr>
+            <a:r>
+              <a:rPr lang="en-US" b="1" dirty="0" err="1"/>
+              <a:t>Github</a:t>
+            </a:r>
+            <a:r>
+              <a:rPr lang="en-US" b="1" dirty="0"/>
+              <a:t> </a:t>
+            </a:r>
+            <a:r>
+              <a:rPr lang="en-US" b="1" dirty="0" err="1"/>
+              <a:t>Url</a:t>
+            </a:r>
+            <a:r>
+              <a:rPr lang="en-US" b="1" dirty="0"/>
+              <a:t>: </a:t>
+            </a:r>
+            <a:r>
+              <a:rPr lang="en-US" dirty="0">
+                <a:hlinkClick r:id="rId2"/>
+              </a:rPr>
+              <a:t>https://</a:t>
+            </a:r>
+            <a:r>
+              <a:rPr lang="en-US" dirty="0" err="1">
+                <a:hlinkClick r:id="rId2"/>
+              </a:rPr>
+              <a:t>github.com</a:t>
+            </a:r>
+            <a:r>
+              <a:rPr lang="en-US" dirty="0">
+                <a:hlinkClick r:id="rId2"/>
+              </a:rPr>
+              <a:t>/Suresh-</a:t>
+            </a:r>
+            <a:r>
+              <a:rPr lang="en-US" dirty="0" err="1">
+                <a:hlinkClick r:id="rId2"/>
+              </a:rPr>
+              <a:t>kumar</a:t>
+            </a:r>
+            <a:r>
+              <a:rPr lang="en-US" dirty="0">
+                <a:hlinkClick r:id="rId2"/>
+              </a:rPr>
+              <a:t>-</a:t>
+            </a:r>
+            <a:r>
+              <a:rPr lang="en-US" dirty="0" err="1">
+                <a:hlinkClick r:id="rId2"/>
+              </a:rPr>
+              <a:t>barawar</a:t>
+            </a:r>
+            <a:r>
+              <a:rPr lang="en-US" dirty="0">
+                <a:hlinkClick r:id="rId2"/>
+              </a:rPr>
+              <a:t>/flutter-task-manager-</a:t>
+            </a:r>
+            <a:r>
+              <a:rPr lang="en-US" dirty="0" err="1">
+                <a:hlinkClick r:id="rId2"/>
+              </a:rPr>
+              <a:t>back4app.git</a:t>
+            </a:r>
+            <a:endParaRPr lang="en-US" dirty="0"/>
+          </a:p>
+          <a:p>
+            <a:pPr>
+              <a:defRPr sz="1800">
+                <a:solidFill>
+                  <a:srgbClr val="52615B"/>
+                </a:solidFill>
+              </a:defRPr>
+            </a:pPr>
+            <a:endParaRPr dirty="0"/>
+          </a:p>
+        </p:txBody>
+      </p:sp>
+      <p:sp>
+        <p:nvSpPr>
+          <p:cNvPr id="5" name="Rectangle 4">
+            <a:extLst>
+              <a:ext uri="{FF2B5EF4-FFF2-40B4-BE49-F238E27FC236}">
+                <a16:creationId xmlns:a16="http://schemas.microsoft.com/office/drawing/2014/main" id="{83A23A58-D3A0-F7C2-C62C-F2ACACDA30AC}"/>
+              </a:ext>
+            </a:extLst>
+          </p:cNvPr>
+          <p:cNvSpPr/>
+          <p:nvPr/>
+        </p:nvSpPr>
+        <p:spPr>
+          <a:xfrm>
+            <a:off x="731520" y="5206481"/>
+            <a:ext cx="4876178" cy="1240037"/>
+          </a:xfrm>
+          <a:prstGeom prst="rect">
+            <a:avLst/>
+          </a:prstGeom>
+          <a:solidFill>
+            <a:srgbClr val="FFFFFF"/>
+          </a:solidFill>
+          <a:ln>
+            <a:solidFill>
+              <a:srgbClr val="E0E4DD"/>
+            </a:solidFill>
+          </a:ln>
+        </p:spPr>
+        <p:style>
+          <a:lnRef idx="1">
+            <a:schemeClr val="accent1"/>
+          </a:lnRef>
+          <a:fillRef idx="3">
+            <a:schemeClr val="accent1"/>
+          </a:fillRef>
+          <a:effectRef idx="2">
+            <a:schemeClr val="accent1"/>
+          </a:effectRef>
+          <a:fontRef idx="minor">
+            <a:schemeClr val="lt1"/>
+          </a:fontRef>
+        </p:style>
+        <p:txBody>
+          <a:bodyPr lIns="320040" tIns="256032" rtlCol="0" anchor="ctr"/>
+          <a:lstStyle/>
+          <a:p>
+            <a:pPr>
+              <a:defRPr sz="2800" b="1">
+                <a:solidFill>
+                  <a:srgbClr val="1F2925"/>
+                </a:solidFill>
+              </a:defRPr>
+            </a:pPr>
+            <a:r>
+              <a:rPr lang="en-US" sz="2400" dirty="0"/>
+              <a:t>Student Name: Suresh Kumar</a:t>
+            </a:r>
+          </a:p>
+          <a:p>
+            <a:pPr>
+              <a:defRPr sz="2800" b="1">
+                <a:solidFill>
+                  <a:srgbClr val="1F2925"/>
+                </a:solidFill>
+              </a:defRPr>
+            </a:pPr>
+            <a:r>
+              <a:rPr lang="en-US" sz="2400" dirty="0"/>
+              <a:t>Bits Id: </a:t>
+            </a:r>
+            <a:r>
+              <a:rPr lang="en-US" sz="2400" dirty="0" err="1"/>
+              <a:t>2024TM93685</a:t>
+            </a:r>
+            <a:endParaRPr sz="2400" dirty="0"/>
+          </a:p>
+        </p:txBody>
+      </p:sp>
+      <p:sp>
+        <p:nvSpPr>
+          <p:cNvPr id="6" name="Rectangle 5">
+            <a:extLst>
+              <a:ext uri="{FF2B5EF4-FFF2-40B4-BE49-F238E27FC236}">
+                <a16:creationId xmlns:a16="http://schemas.microsoft.com/office/drawing/2014/main" id="{C213A4C6-B35B-2298-7236-42C4F0E39CCB}"/>
+              </a:ext>
+            </a:extLst>
+          </p:cNvPr>
+          <p:cNvSpPr/>
+          <p:nvPr/>
+        </p:nvSpPr>
+        <p:spPr>
+          <a:xfrm>
+            <a:off x="6466114" y="5206481"/>
+            <a:ext cx="4994366" cy="1240037"/>
+          </a:xfrm>
+          <a:prstGeom prst="rect">
+            <a:avLst/>
+          </a:prstGeom>
+          <a:solidFill>
+            <a:srgbClr val="FFFFFF"/>
+          </a:solidFill>
+          <a:ln>
+            <a:solidFill>
+              <a:srgbClr val="E0E4DD"/>
+            </a:solidFill>
+          </a:ln>
+        </p:spPr>
+        <p:style>
+          <a:lnRef idx="1">
+            <a:schemeClr val="accent1"/>
+          </a:lnRef>
+          <a:fillRef idx="3">
+            <a:schemeClr val="accent1"/>
+          </a:fillRef>
+          <a:effectRef idx="2">
+            <a:schemeClr val="accent1"/>
+          </a:effectRef>
+          <a:fontRef idx="minor">
+            <a:schemeClr val="lt1"/>
+          </a:fontRef>
+        </p:style>
+        <p:txBody>
+          <a:bodyPr lIns="320040" tIns="256032" rtlCol="0" anchor="ctr"/>
+          <a:lstStyle/>
+          <a:p>
+            <a:pPr>
+              <a:defRPr sz="2800" b="1">
+                <a:solidFill>
+                  <a:srgbClr val="1F2925"/>
+                </a:solidFill>
+              </a:defRPr>
+            </a:pPr>
+            <a:r>
+              <a:rPr lang="en-US" sz="2400" dirty="0"/>
+              <a:t>Course Name: Cross Platform Application Development</a:t>
             </a:r>
           </a:p>
         </p:txBody>
@@ -3248,8 +3504,8 @@
 </p:sld>
 </file>
 
-<file path=ppt/slides/slide2.xml><?xml version="1.0" encoding="utf-8"?>
-<p:sld xmlns:a="http://schemas.openxmlformats.org/drawingml/2006/main" xmlns:p="http://schemas.openxmlformats.org/presentationml/2006/main" xmlns:r="http://schemas.openxmlformats.org/officeDocument/2006/relationships">
+<file path=ppt/slides/slide10.xml><?xml version="1.0" encoding="utf-8"?>
+<p:sld xmlns:a="http://schemas.openxmlformats.org/drawingml/2006/main" xmlns:r="http://schemas.openxmlformats.org/officeDocument/2006/relationships" xmlns:p="http://schemas.openxmlformats.org/presentationml/2006/main">
   <p:cSld>
     <p:bg>
       <p:bgPr>
@@ -3265,7 +3521,14 @@
         <p:cNvGrpSpPr/>
         <p:nvPr/>
       </p:nvGrpSpPr>
-      <p:grpSpPr/>
+      <p:grpSpPr>
+        <a:xfrm>
+          <a:off x="0" y="0"/>
+          <a:ext cx="0" cy="0"/>
+          <a:chOff x="0" y="0"/>
+          <a:chExt cx="0" cy="0"/>
+        </a:xfrm>
+      </p:grpSpPr>
       <p:sp>
         <p:nvSpPr>
           <p:cNvPr id="2" name="TextBox 1"/>
@@ -3289,14 +3552,14 @@
           <a:lstStyle/>
           <a:p>
             <a:pPr>
-              <a:defRPr b="1" sz="3400">
+              <a:defRPr sz="3400" b="1">
                 <a:solidFill>
                   <a:srgbClr val="1F2925"/>
                 </a:solidFill>
               </a:defRPr>
             </a:pPr>
             <a:r>
-              <a:t>Project Overview</a:t>
+              <a:t>Demo Checklist</a:t>
             </a:r>
           </a:p>
         </p:txBody>
@@ -3334,7 +3597,7 @@
               </a:defRPr>
             </a:pPr>
             <a:r>
-              <a:t>A cross-platform Flutter app for managing personal student tasks.</a:t>
+              <a:t>Register using a student email ID.</a:t>
             </a:r>
           </a:p>
           <a:p>
@@ -3349,7 +3612,7 @@
               </a:defRPr>
             </a:pPr>
             <a:r>
-              <a:t>Back4App provides authentication, database storage, and Parse APIs.</a:t>
+              <a:t>Create a new task.</a:t>
             </a:r>
           </a:p>
           <a:p>
@@ -3364,7 +3627,7 @@
               </a:defRPr>
             </a:pPr>
             <a:r>
-              <a:t>Users can register, log in, create tasks, edit details, mark completion, delete tasks, and log out.</a:t>
+              <a:t>Edit task title or description.</a:t>
             </a:r>
           </a:p>
           <a:p>
@@ -3379,7 +3642,52 @@
               </a:defRPr>
             </a:pPr>
             <a:r>
-              <a:t>Each task belongs to the logged-in user and is protected with object-level ACL.</a:t>
+              <a:t>Mark the task as completed.</a:t>
+            </a:r>
+          </a:p>
+          <a:p>
+            <a:pPr>
+              <a:spcAft>
+                <a:spcPts val="1000"/>
+              </a:spcAft>
+              <a:defRPr sz="2000">
+                <a:solidFill>
+                  <a:srgbClr val="1F2925"/>
+                </a:solidFill>
+              </a:defRPr>
+            </a:pPr>
+            <a:r>
+              <a:t>Delete the task.</a:t>
+            </a:r>
+          </a:p>
+          <a:p>
+            <a:pPr>
+              <a:spcAft>
+                <a:spcPts val="1000"/>
+              </a:spcAft>
+              <a:defRPr sz="2000">
+                <a:solidFill>
+                  <a:srgbClr val="1F2925"/>
+                </a:solidFill>
+              </a:defRPr>
+            </a:pPr>
+            <a:r>
+              <a:t>Logout securely.</a:t>
+            </a:r>
+          </a:p>
+          <a:p>
+            <a:pPr>
+              <a:spcAft>
+                <a:spcPts val="1000"/>
+              </a:spcAft>
+              <a:defRPr sz="2000">
+                <a:solidFill>
+                  <a:srgbClr val="1F2925"/>
+                </a:solidFill>
+              </a:defRPr>
+            </a:pPr>
+            <a:r>
+              <a:t>Submit YouTube video link, GitHub repository, and this PPT on Taxila.</a:t>
             </a:r>
           </a:p>
         </p:txBody>
@@ -3392,8 +3700,8 @@
 </p:sld>
 </file>
 
-<file path=ppt/slides/slide3.xml><?xml version="1.0" encoding="utf-8"?>
-<p:sld xmlns:a="http://schemas.openxmlformats.org/drawingml/2006/main" xmlns:p="http://schemas.openxmlformats.org/presentationml/2006/main" xmlns:r="http://schemas.openxmlformats.org/officeDocument/2006/relationships">
+<file path=ppt/slides/slide2.xml><?xml version="1.0" encoding="utf-8"?>
+<p:sld xmlns:a="http://schemas.openxmlformats.org/drawingml/2006/main" xmlns:r="http://schemas.openxmlformats.org/officeDocument/2006/relationships" xmlns:p="http://schemas.openxmlformats.org/presentationml/2006/main">
   <p:cSld>
     <p:bg>
       <p:bgPr>
@@ -3409,7 +3717,14 @@
         <p:cNvGrpSpPr/>
         <p:nvPr/>
       </p:nvGrpSpPr>
-      <p:grpSpPr/>
+      <p:grpSpPr>
+        <a:xfrm>
+          <a:off x="0" y="0"/>
+          <a:ext cx="0" cy="0"/>
+          <a:chOff x="0" y="0"/>
+          <a:chExt cx="0" cy="0"/>
+        </a:xfrm>
+      </p:grpSpPr>
       <p:sp>
         <p:nvSpPr>
           <p:cNvPr id="2" name="TextBox 1"/>
@@ -3433,7 +3748,158 @@
           <a:lstStyle/>
           <a:p>
             <a:pPr>
-              <a:defRPr b="1" sz="3400">
+              <a:defRPr sz="3400" b="1">
+                <a:solidFill>
+                  <a:srgbClr val="1F2925"/>
+                </a:solidFill>
+              </a:defRPr>
+            </a:pPr>
+            <a:r>
+              <a:t>Project Overview</a:t>
+            </a:r>
+          </a:p>
+        </p:txBody>
+      </p:sp>
+      <p:sp>
+        <p:nvSpPr>
+          <p:cNvPr id="3" name="TextBox 2"/>
+          <p:cNvSpPr txBox="1"/>
+          <p:nvPr/>
+        </p:nvSpPr>
+        <p:spPr>
+          <a:xfrm>
+            <a:off x="777240" y="1691640"/>
+            <a:ext cx="10698480" cy="4389120"/>
+          </a:xfrm>
+          <a:prstGeom prst="rect">
+            <a:avLst/>
+          </a:prstGeom>
+          <a:noFill/>
+        </p:spPr>
+        <p:txBody>
+          <a:bodyPr wrap="none">
+            <a:spAutoFit/>
+          </a:bodyPr>
+          <a:lstStyle/>
+          <a:p>
+            <a:pPr>
+              <a:spcAft>
+                <a:spcPts val="1000"/>
+              </a:spcAft>
+              <a:defRPr sz="2000">
+                <a:solidFill>
+                  <a:srgbClr val="1F2925"/>
+                </a:solidFill>
+              </a:defRPr>
+            </a:pPr>
+            <a:r>
+              <a:t>A cross-platform Flutter app for managing personal student tasks.</a:t>
+            </a:r>
+          </a:p>
+          <a:p>
+            <a:pPr>
+              <a:spcAft>
+                <a:spcPts val="1000"/>
+              </a:spcAft>
+              <a:defRPr sz="2000">
+                <a:solidFill>
+                  <a:srgbClr val="1F2925"/>
+                </a:solidFill>
+              </a:defRPr>
+            </a:pPr>
+            <a:r>
+              <a:t>Back4App provides authentication, database storage, and Parse APIs.</a:t>
+            </a:r>
+          </a:p>
+          <a:p>
+            <a:pPr>
+              <a:spcAft>
+                <a:spcPts val="1000"/>
+              </a:spcAft>
+              <a:defRPr sz="2000">
+                <a:solidFill>
+                  <a:srgbClr val="1F2925"/>
+                </a:solidFill>
+              </a:defRPr>
+            </a:pPr>
+            <a:r>
+              <a:t>Users can register, log in, create tasks, edit details, mark completion, delete tasks, and log out.</a:t>
+            </a:r>
+          </a:p>
+          <a:p>
+            <a:pPr>
+              <a:spcAft>
+                <a:spcPts val="1000"/>
+              </a:spcAft>
+              <a:defRPr sz="2000">
+                <a:solidFill>
+                  <a:srgbClr val="1F2925"/>
+                </a:solidFill>
+              </a:defRPr>
+            </a:pPr>
+            <a:r>
+              <a:t>Each task belongs to the logged-in user and is protected with object-level ACL.</a:t>
+            </a:r>
+          </a:p>
+        </p:txBody>
+      </p:sp>
+    </p:spTree>
+  </p:cSld>
+  <p:clrMapOvr>
+    <a:masterClrMapping/>
+  </p:clrMapOvr>
+</p:sld>
+</file>
+
+<file path=ppt/slides/slide3.xml><?xml version="1.0" encoding="utf-8"?>
+<p:sld xmlns:a="http://schemas.openxmlformats.org/drawingml/2006/main" xmlns:r="http://schemas.openxmlformats.org/officeDocument/2006/relationships" xmlns:p="http://schemas.openxmlformats.org/presentationml/2006/main">
+  <p:cSld>
+    <p:bg>
+      <p:bgPr>
+        <a:solidFill>
+          <a:srgbClr val="F7F8F5"/>
+        </a:solidFill>
+        <a:effectLst/>
+      </p:bgPr>
+    </p:bg>
+    <p:spTree>
+      <p:nvGrpSpPr>
+        <p:cNvPr id="1" name=""/>
+        <p:cNvGrpSpPr/>
+        <p:nvPr/>
+      </p:nvGrpSpPr>
+      <p:grpSpPr>
+        <a:xfrm>
+          <a:off x="0" y="0"/>
+          <a:ext cx="0" cy="0"/>
+          <a:chOff x="0" y="0"/>
+          <a:chExt cx="0" cy="0"/>
+        </a:xfrm>
+      </p:grpSpPr>
+      <p:sp>
+        <p:nvSpPr>
+          <p:cNvPr id="2" name="TextBox 1"/>
+          <p:cNvSpPr txBox="1"/>
+          <p:nvPr/>
+        </p:nvSpPr>
+        <p:spPr>
+          <a:xfrm>
+            <a:off x="594360" y="411480"/>
+            <a:ext cx="10972800" cy="731520"/>
+          </a:xfrm>
+          <a:prstGeom prst="rect">
+            <a:avLst/>
+          </a:prstGeom>
+          <a:noFill/>
+        </p:spPr>
+        <p:txBody>
+          <a:bodyPr wrap="none">
+            <a:spAutoFit/>
+          </a:bodyPr>
+          <a:lstStyle/>
+          <a:p>
+            <a:pPr>
+              <a:defRPr sz="3400" b="1">
                 <a:solidFill>
                   <a:srgbClr val="1F2925"/>
                 </a:solidFill>
@@ -3483,11 +3949,11 @@
           </a:fontRef>
         </p:style>
         <p:txBody>
-          <a:bodyPr rtlCol="0" anchor="ctr" lIns="164592" rIns="164592" tIns="109728"/>
+          <a:bodyPr lIns="164592" tIns="109728" rIns="164592" rtlCol="0" anchor="ctr"/>
           <a:lstStyle/>
           <a:p>
             <a:pPr algn="ctr">
-              <a:defRPr b="1" sz="1800">
+              <a:defRPr sz="1800" b="1">
                 <a:solidFill>
                   <a:srgbClr val="2E7D6A"/>
                 </a:solidFill>
@@ -3549,11 +4015,11 @@
           </a:fontRef>
         </p:style>
         <p:txBody>
-          <a:bodyPr rtlCol="0" anchor="ctr" lIns="164592" rIns="164592" tIns="109728"/>
+          <a:bodyPr lIns="164592" tIns="109728" rIns="164592" rtlCol="0" anchor="ctr"/>
           <a:lstStyle/>
           <a:p>
             <a:pPr algn="ctr">
-              <a:defRPr b="1" sz="1800">
+              <a:defRPr sz="1800" b="1">
                 <a:solidFill>
                   <a:srgbClr val="2E7D6A"/>
                 </a:solidFill>
@@ -3615,11 +4081,11 @@
           </a:fontRef>
         </p:style>
         <p:txBody>
-          <a:bodyPr rtlCol="0" anchor="ctr" lIns="164592" rIns="164592" tIns="109728"/>
+          <a:bodyPr lIns="164592" tIns="109728" rIns="164592" rtlCol="0" anchor="ctr"/>
           <a:lstStyle/>
           <a:p>
             <a:pPr algn="ctr">
-              <a:defRPr b="1" sz="1800">
+              <a:defRPr sz="1800" b="1">
                 <a:solidFill>
                   <a:srgbClr val="2E7D6A"/>
                 </a:solidFill>
@@ -3681,11 +4147,11 @@
           </a:fontRef>
         </p:style>
         <p:txBody>
-          <a:bodyPr rtlCol="0" anchor="ctr" lIns="164592" rIns="164592" tIns="109728"/>
+          <a:bodyPr lIns="164592" tIns="109728" rIns="164592" rtlCol="0" anchor="ctr"/>
           <a:lstStyle/>
           <a:p>
             <a:pPr algn="ctr">
-              <a:defRPr b="1" sz="1800">
+              <a:defRPr sz="1800" b="1">
                 <a:solidFill>
                   <a:srgbClr val="2E7D6A"/>
                 </a:solidFill>
@@ -3747,11 +4213,11 @@
           </a:fontRef>
         </p:style>
         <p:txBody>
-          <a:bodyPr rtlCol="0" anchor="ctr" lIns="164592" rIns="164592" tIns="109728"/>
+          <a:bodyPr lIns="164592" tIns="109728" rIns="164592" rtlCol="0" anchor="ctr"/>
           <a:lstStyle/>
           <a:p>
             <a:pPr algn="ctr">
-              <a:defRPr b="1" sz="1800">
+              <a:defRPr sz="1800" b="1">
                 <a:solidFill>
                   <a:srgbClr val="2E7D6A"/>
                 </a:solidFill>
@@ -3784,7 +4250,7 @@
 </file>
 
 <file path=ppt/slides/slide4.xml><?xml version="1.0" encoding="utf-8"?>
-<p:sld xmlns:a="http://schemas.openxmlformats.org/drawingml/2006/main" xmlns:p="http://schemas.openxmlformats.org/presentationml/2006/main" xmlns:r="http://schemas.openxmlformats.org/officeDocument/2006/relationships">
+<p:sld xmlns:a="http://schemas.openxmlformats.org/drawingml/2006/main" xmlns:r="http://schemas.openxmlformats.org/officeDocument/2006/relationships" xmlns:p="http://schemas.openxmlformats.org/presentationml/2006/main">
   <p:cSld>
     <p:bg>
       <p:bgPr>
@@ -3800,7 +4266,14 @@
         <p:cNvGrpSpPr/>
         <p:nvPr/>
       </p:nvGrpSpPr>
-      <p:grpSpPr/>
+      <p:grpSpPr>
+        <a:xfrm>
+          <a:off x="0" y="0"/>
+          <a:ext cx="0" cy="0"/>
+          <a:chOff x="0" y="0"/>
+          <a:chExt cx="0" cy="0"/>
+        </a:xfrm>
+      </p:grpSpPr>
       <p:sp>
         <p:nvSpPr>
           <p:cNvPr id="2" name="TextBox 1"/>
@@ -3824,7 +4297,7 @@
           <a:lstStyle/>
           <a:p>
             <a:pPr>
-              <a:defRPr b="1" sz="3400">
+              <a:defRPr sz="3400" b="1">
                 <a:solidFill>
                   <a:srgbClr val="1F2925"/>
                 </a:solidFill>
@@ -3958,7 +4431,411 @@
 </file>
 
 <file path=ppt/slides/slide5.xml><?xml version="1.0" encoding="utf-8"?>
-<p:sld xmlns:a="http://schemas.openxmlformats.org/drawingml/2006/main" xmlns:p="http://schemas.openxmlformats.org/presentationml/2006/main" xmlns:r="http://schemas.openxmlformats.org/officeDocument/2006/relationships">
+<p:sld xmlns:a="http://schemas.openxmlformats.org/drawingml/2006/main" xmlns:r="http://schemas.openxmlformats.org/officeDocument/2006/relationships" xmlns:p="http://schemas.openxmlformats.org/presentationml/2006/main">
+  <p:cSld>
+    <p:bg>
+      <p:bgPr>
+        <a:solidFill>
+          <a:srgbClr val="F7F8F5"/>
+        </a:solidFill>
+        <a:effectLst/>
+      </p:bgPr>
+    </p:bg>
+    <p:spTree>
+      <p:nvGrpSpPr>
+        <p:cNvPr id="1" name="">
+          <a:extLst>
+            <a:ext uri="{FF2B5EF4-FFF2-40B4-BE49-F238E27FC236}">
+              <a16:creationId xmlns:a16="http://schemas.microsoft.com/office/drawing/2014/main" id="{B1072A08-46E4-9D73-D1A1-CB3334D09DF1}"/>
+            </a:ext>
+          </a:extLst>
+        </p:cNvPr>
+        <p:cNvGrpSpPr/>
+        <p:nvPr/>
+      </p:nvGrpSpPr>
+      <p:grpSpPr>
+        <a:xfrm>
+          <a:off x="0" y="0"/>
+          <a:ext cx="0" cy="0"/>
+          <a:chOff x="0" y="0"/>
+          <a:chExt cx="0" cy="0"/>
+        </a:xfrm>
+      </p:grpSpPr>
+      <p:sp>
+        <p:nvSpPr>
+          <p:cNvPr id="2" name="TextBox 1">
+            <a:extLst>
+              <a:ext uri="{FF2B5EF4-FFF2-40B4-BE49-F238E27FC236}">
+                <a16:creationId xmlns:a16="http://schemas.microsoft.com/office/drawing/2014/main" id="{E7E21A45-0240-6C0B-5870-99171D153258}"/>
+              </a:ext>
+            </a:extLst>
+          </p:cNvPr>
+          <p:cNvSpPr txBox="1"/>
+          <p:nvPr/>
+        </p:nvSpPr>
+        <p:spPr>
+          <a:xfrm>
+            <a:off x="594360" y="103703"/>
+            <a:ext cx="4864345" cy="615553"/>
+          </a:xfrm>
+          <a:prstGeom prst="rect">
+            <a:avLst/>
+          </a:prstGeom>
+          <a:noFill/>
+        </p:spPr>
+        <p:txBody>
+          <a:bodyPr wrap="none">
+            <a:spAutoFit/>
+          </a:bodyPr>
+          <a:lstStyle/>
+          <a:p>
+            <a:pPr>
+              <a:defRPr sz="3400" b="1">
+                <a:solidFill>
+                  <a:srgbClr val="1F2925"/>
+                </a:solidFill>
+              </a:defRPr>
+            </a:pPr>
+            <a:r>
+              <a:rPr lang="en-US" dirty="0"/>
+              <a:t>Login/Register Dashboard</a:t>
+            </a:r>
+            <a:endParaRPr dirty="0"/>
+          </a:p>
+        </p:txBody>
+      </p:sp>
+      <p:pic>
+        <p:nvPicPr>
+          <p:cNvPr id="9" name="Picture 8">
+            <a:extLst>
+              <a:ext uri="{FF2B5EF4-FFF2-40B4-BE49-F238E27FC236}">
+                <a16:creationId xmlns:a16="http://schemas.microsoft.com/office/drawing/2014/main" id="{57A1FF25-AB46-6DAA-ACCC-77A4F66CFC16}"/>
+              </a:ext>
+            </a:extLst>
+          </p:cNvPr>
+          <p:cNvPicPr>
+            <a:picLocks noChangeAspect="1"/>
+          </p:cNvPicPr>
+          <p:nvPr/>
+        </p:nvPicPr>
+        <p:blipFill>
+          <a:blip r:embed="rId2"/>
+          <a:stretch>
+            <a:fillRect/>
+          </a:stretch>
+        </p:blipFill>
+        <p:spPr>
+          <a:xfrm>
+            <a:off x="594360" y="719255"/>
+            <a:ext cx="4736377" cy="2401966"/>
+          </a:xfrm>
+          <a:prstGeom prst="rect">
+            <a:avLst/>
+          </a:prstGeom>
+          <a:ln>
+            <a:noFill/>
+          </a:ln>
+          <a:effectLst>
+            <a:outerShdw blurRad="57785" dist="33020" dir="3180000" algn="ctr">
+              <a:srgbClr val="000000">
+                <a:alpha val="30000"/>
+              </a:srgbClr>
+            </a:outerShdw>
+          </a:effectLst>
+          <a:scene3d>
+            <a:camera prst="orthographicFront">
+              <a:rot lat="0" lon="0" rev="0"/>
+            </a:camera>
+            <a:lightRig rig="brightRoom" dir="t">
+              <a:rot lat="0" lon="0" rev="600000"/>
+            </a:lightRig>
+          </a:scene3d>
+          <a:sp3d prstMaterial="metal">
+            <a:bevelT w="38100" h="57150" prst="angle"/>
+          </a:sp3d>
+        </p:spPr>
+      </p:pic>
+      <p:pic>
+        <p:nvPicPr>
+          <p:cNvPr id="11" name="Picture 10">
+            <a:extLst>
+              <a:ext uri="{FF2B5EF4-FFF2-40B4-BE49-F238E27FC236}">
+                <a16:creationId xmlns:a16="http://schemas.microsoft.com/office/drawing/2014/main" id="{B8593FD0-E1E2-8C5D-BB6E-A1551F4E192F}"/>
+              </a:ext>
+            </a:extLst>
+          </p:cNvPr>
+          <p:cNvPicPr>
+            <a:picLocks noChangeAspect="1"/>
+          </p:cNvPicPr>
+          <p:nvPr/>
+        </p:nvPicPr>
+        <p:blipFill>
+          <a:blip r:embed="rId3"/>
+          <a:stretch>
+            <a:fillRect/>
+          </a:stretch>
+        </p:blipFill>
+        <p:spPr>
+          <a:xfrm>
+            <a:off x="642556" y="3582122"/>
+            <a:ext cx="6111001" cy="3122830"/>
+          </a:xfrm>
+          <a:prstGeom prst="rect">
+            <a:avLst/>
+          </a:prstGeom>
+          <a:ln>
+            <a:noFill/>
+          </a:ln>
+          <a:effectLst>
+            <a:outerShdw blurRad="57785" dist="33020" dir="3180000" algn="ctr">
+              <a:srgbClr val="000000">
+                <a:alpha val="30000"/>
+              </a:srgbClr>
+            </a:outerShdw>
+          </a:effectLst>
+          <a:scene3d>
+            <a:camera prst="orthographicFront">
+              <a:rot lat="0" lon="0" rev="0"/>
+            </a:camera>
+            <a:lightRig rig="brightRoom" dir="t">
+              <a:rot lat="0" lon="0" rev="600000"/>
+            </a:lightRig>
+          </a:scene3d>
+          <a:sp3d prstMaterial="metal">
+            <a:bevelT w="38100" h="57150" prst="angle"/>
+          </a:sp3d>
+        </p:spPr>
+      </p:pic>
+      <p:sp>
+        <p:nvSpPr>
+          <p:cNvPr id="13" name="TextBox 12">
+            <a:extLst>
+              <a:ext uri="{FF2B5EF4-FFF2-40B4-BE49-F238E27FC236}">
+                <a16:creationId xmlns:a16="http://schemas.microsoft.com/office/drawing/2014/main" id="{CEE1205A-A91E-A1DD-4AF5-FF13BC9712FD}"/>
+              </a:ext>
+            </a:extLst>
+          </p:cNvPr>
+          <p:cNvSpPr txBox="1"/>
+          <p:nvPr/>
+        </p:nvSpPr>
+        <p:spPr>
+          <a:xfrm>
+            <a:off x="583674" y="3043895"/>
+            <a:ext cx="1852367" cy="615553"/>
+          </a:xfrm>
+          <a:prstGeom prst="rect">
+            <a:avLst/>
+          </a:prstGeom>
+          <a:noFill/>
+        </p:spPr>
+        <p:txBody>
+          <a:bodyPr wrap="none">
+            <a:spAutoFit/>
+          </a:bodyPr>
+          <a:lstStyle/>
+          <a:p>
+            <a:pPr>
+              <a:defRPr sz="3400" b="1">
+                <a:solidFill>
+                  <a:srgbClr val="1F2925"/>
+                </a:solidFill>
+              </a:defRPr>
+            </a:pPr>
+            <a:r>
+              <a:rPr lang="en-US" dirty="0"/>
+              <a:t>Task Lists</a:t>
+            </a:r>
+            <a:endParaRPr dirty="0"/>
+          </a:p>
+        </p:txBody>
+      </p:sp>
+      <p:sp>
+        <p:nvSpPr>
+          <p:cNvPr id="14" name="TextBox 13">
+            <a:extLst>
+              <a:ext uri="{FF2B5EF4-FFF2-40B4-BE49-F238E27FC236}">
+                <a16:creationId xmlns:a16="http://schemas.microsoft.com/office/drawing/2014/main" id="{06BB4471-65E5-23D2-7B65-EF8358E7AABF}"/>
+              </a:ext>
+            </a:extLst>
+          </p:cNvPr>
+          <p:cNvSpPr txBox="1"/>
+          <p:nvPr/>
+        </p:nvSpPr>
+        <p:spPr>
+          <a:xfrm>
+            <a:off x="6563070" y="690289"/>
+            <a:ext cx="1797928" cy="615553"/>
+          </a:xfrm>
+          <a:prstGeom prst="rect">
+            <a:avLst/>
+          </a:prstGeom>
+          <a:noFill/>
+        </p:spPr>
+        <p:txBody>
+          <a:bodyPr wrap="none">
+            <a:spAutoFit/>
+          </a:bodyPr>
+          <a:lstStyle/>
+          <a:p>
+            <a:pPr>
+              <a:defRPr sz="3400" b="1">
+                <a:solidFill>
+                  <a:srgbClr val="1F2925"/>
+                </a:solidFill>
+              </a:defRPr>
+            </a:pPr>
+            <a:r>
+              <a:rPr lang="en-US" dirty="0"/>
+              <a:t>Add Task</a:t>
+            </a:r>
+            <a:endParaRPr dirty="0"/>
+          </a:p>
+        </p:txBody>
+      </p:sp>
+      <p:pic>
+        <p:nvPicPr>
+          <p:cNvPr id="16" name="Picture 15">
+            <a:extLst>
+              <a:ext uri="{FF2B5EF4-FFF2-40B4-BE49-F238E27FC236}">
+                <a16:creationId xmlns:a16="http://schemas.microsoft.com/office/drawing/2014/main" id="{3DF1EB99-87D7-1951-868B-144351B1F754}"/>
+              </a:ext>
+            </a:extLst>
+          </p:cNvPr>
+          <p:cNvPicPr>
+            <a:picLocks noChangeAspect="1"/>
+          </p:cNvPicPr>
+          <p:nvPr/>
+        </p:nvPicPr>
+        <p:blipFill>
+          <a:blip r:embed="rId4"/>
+          <a:stretch>
+            <a:fillRect/>
+          </a:stretch>
+        </p:blipFill>
+        <p:spPr>
+          <a:xfrm>
+            <a:off x="8360998" y="114099"/>
+            <a:ext cx="3086531" cy="3353268"/>
+          </a:xfrm>
+          <a:prstGeom prst="rect">
+            <a:avLst/>
+          </a:prstGeom>
+          <a:ln>
+            <a:noFill/>
+          </a:ln>
+          <a:effectLst>
+            <a:softEdge rad="112500"/>
+          </a:effectLst>
+        </p:spPr>
+      </p:pic>
+      <p:sp>
+        <p:nvSpPr>
+          <p:cNvPr id="17" name="TextBox 16">
+            <a:extLst>
+              <a:ext uri="{FF2B5EF4-FFF2-40B4-BE49-F238E27FC236}">
+                <a16:creationId xmlns:a16="http://schemas.microsoft.com/office/drawing/2014/main" id="{7A8C7646-0EAD-7D14-C33A-D9EE5969B26E}"/>
+              </a:ext>
+            </a:extLst>
+          </p:cNvPr>
+          <p:cNvSpPr txBox="1"/>
+          <p:nvPr/>
+        </p:nvSpPr>
+        <p:spPr>
+          <a:xfrm>
+            <a:off x="6988850" y="3305444"/>
+            <a:ext cx="2027158" cy="615553"/>
+          </a:xfrm>
+          <a:prstGeom prst="rect">
+            <a:avLst/>
+          </a:prstGeom>
+          <a:noFill/>
+        </p:spPr>
+        <p:txBody>
+          <a:bodyPr wrap="none">
+            <a:spAutoFit/>
+          </a:bodyPr>
+          <a:lstStyle/>
+          <a:p>
+            <a:pPr>
+              <a:defRPr sz="3400" b="1">
+                <a:solidFill>
+                  <a:srgbClr val="1F2925"/>
+                </a:solidFill>
+              </a:defRPr>
+            </a:pPr>
+            <a:r>
+              <a:rPr lang="en-US" dirty="0"/>
+              <a:t>Done Task</a:t>
+            </a:r>
+          </a:p>
+        </p:txBody>
+      </p:sp>
+      <p:pic>
+        <p:nvPicPr>
+          <p:cNvPr id="19" name="Picture 18">
+            <a:extLst>
+              <a:ext uri="{FF2B5EF4-FFF2-40B4-BE49-F238E27FC236}">
+                <a16:creationId xmlns:a16="http://schemas.microsoft.com/office/drawing/2014/main" id="{5AEA7F49-8A61-9327-9A9F-9975C62F920D}"/>
+              </a:ext>
+            </a:extLst>
+          </p:cNvPr>
+          <p:cNvPicPr>
+            <a:picLocks noChangeAspect="1"/>
+          </p:cNvPicPr>
+          <p:nvPr/>
+        </p:nvPicPr>
+        <p:blipFill>
+          <a:blip r:embed="rId5"/>
+          <a:stretch>
+            <a:fillRect/>
+          </a:stretch>
+        </p:blipFill>
+        <p:spPr>
+          <a:xfrm>
+            <a:off x="8250866" y="3876700"/>
+            <a:ext cx="3346774" cy="2744709"/>
+          </a:xfrm>
+          <a:prstGeom prst="rect">
+            <a:avLst/>
+          </a:prstGeom>
+          <a:ln>
+            <a:noFill/>
+          </a:ln>
+          <a:effectLst>
+            <a:outerShdw blurRad="57785" dist="33020" dir="3180000" algn="ctr">
+              <a:srgbClr val="000000">
+                <a:alpha val="30000"/>
+              </a:srgbClr>
+            </a:outerShdw>
+          </a:effectLst>
+          <a:scene3d>
+            <a:camera prst="orthographicFront">
+              <a:rot lat="0" lon="0" rev="0"/>
+            </a:camera>
+            <a:lightRig rig="brightRoom" dir="t">
+              <a:rot lat="0" lon="0" rev="600000"/>
+            </a:lightRig>
+          </a:scene3d>
+          <a:sp3d prstMaterial="metal">
+            <a:bevelT w="38100" h="57150" prst="angle"/>
+          </a:sp3d>
+        </p:spPr>
+      </p:pic>
+    </p:spTree>
+    <p:extLst>
+      <p:ext uri="{BB962C8B-B14F-4D97-AF65-F5344CB8AC3E}">
+        <p14:creationId xmlns:p14="http://schemas.microsoft.com/office/powerpoint/2010/main" val="2866483851"/>
+      </p:ext>
+    </p:extLst>
+  </p:cSld>
+  <p:clrMapOvr>
+    <a:masterClrMapping/>
+  </p:clrMapOvr>
+</p:sld>
+</file>
+
+<file path=ppt/slides/slide6.xml><?xml version="1.0" encoding="utf-8"?>
+<p:sld xmlns:a="http://schemas.openxmlformats.org/drawingml/2006/main" xmlns:r="http://schemas.openxmlformats.org/officeDocument/2006/relationships" xmlns:p="http://schemas.openxmlformats.org/presentationml/2006/main">
   <p:cSld>
     <p:bg>
       <p:bgPr>
@@ -3974,7 +4851,14 @@
         <p:cNvGrpSpPr/>
         <p:nvPr/>
       </p:nvGrpSpPr>
-      <p:grpSpPr/>
+      <p:grpSpPr>
+        <a:xfrm>
+          <a:off x="0" y="0"/>
+          <a:ext cx="0" cy="0"/>
+          <a:chOff x="0" y="0"/>
+          <a:chExt cx="0" cy="0"/>
+        </a:xfrm>
+      </p:grpSpPr>
       <p:sp>
         <p:nvSpPr>
           <p:cNvPr id="2" name="TextBox 1"/>
@@ -3998,7 +4882,7 @@
           <a:lstStyle/>
           <a:p>
             <a:pPr>
-              <a:defRPr b="1" sz="3400">
+              <a:defRPr sz="3400" b="1">
                 <a:solidFill>
                   <a:srgbClr val="1F2925"/>
                 </a:solidFill>
@@ -4048,11 +4932,11 @@
           </a:fontRef>
         </p:style>
         <p:txBody>
-          <a:bodyPr rtlCol="0" anchor="ctr" lIns="164592" rIns="164592" tIns="109728"/>
+          <a:bodyPr lIns="164592" tIns="109728" rIns="164592" rtlCol="0" anchor="ctr"/>
           <a:lstStyle/>
           <a:p>
             <a:pPr algn="ctr">
-              <a:defRPr b="1" sz="1800">
+              <a:defRPr sz="1800" b="1">
                 <a:solidFill>
                   <a:srgbClr val="2E7D6A"/>
                 </a:solidFill>
@@ -4114,11 +4998,11 @@
           </a:fontRef>
         </p:style>
         <p:txBody>
-          <a:bodyPr rtlCol="0" anchor="ctr" lIns="164592" rIns="164592" tIns="109728"/>
+          <a:bodyPr lIns="164592" tIns="109728" rIns="164592" rtlCol="0" anchor="ctr"/>
           <a:lstStyle/>
           <a:p>
             <a:pPr algn="ctr">
-              <a:defRPr b="1" sz="1800">
+              <a:defRPr sz="1800" b="1">
                 <a:solidFill>
                   <a:srgbClr val="2E7D6A"/>
                 </a:solidFill>
@@ -4180,11 +5064,11 @@
           </a:fontRef>
         </p:style>
         <p:txBody>
-          <a:bodyPr rtlCol="0" anchor="ctr" lIns="164592" rIns="164592" tIns="109728"/>
+          <a:bodyPr lIns="164592" tIns="109728" rIns="164592" rtlCol="0" anchor="ctr"/>
           <a:lstStyle/>
           <a:p>
             <a:pPr algn="ctr">
-              <a:defRPr b="1" sz="1800">
+              <a:defRPr sz="1800" b="1">
                 <a:solidFill>
                   <a:srgbClr val="2E7D6A"/>
                 </a:solidFill>
@@ -4246,11 +5130,11 @@
           </a:fontRef>
         </p:style>
         <p:txBody>
-          <a:bodyPr rtlCol="0" anchor="ctr" lIns="164592" rIns="164592" tIns="109728"/>
+          <a:bodyPr lIns="164592" tIns="109728" rIns="164592" rtlCol="0" anchor="ctr"/>
           <a:lstStyle/>
           <a:p>
             <a:pPr algn="ctr">
-              <a:defRPr b="1" sz="1800">
+              <a:defRPr sz="1800" b="1">
                 <a:solidFill>
                   <a:srgbClr val="2E7D6A"/>
                 </a:solidFill>
@@ -4312,11 +5196,11 @@
           </a:fontRef>
         </p:style>
         <p:txBody>
-          <a:bodyPr rtlCol="0" anchor="ctr" lIns="164592" rIns="164592" tIns="109728"/>
+          <a:bodyPr lIns="164592" tIns="109728" rIns="164592" rtlCol="0" anchor="ctr"/>
           <a:lstStyle/>
           <a:p>
             <a:pPr algn="ctr">
-              <a:defRPr b="1" sz="1800">
+              <a:defRPr sz="1800" b="1">
                 <a:solidFill>
                   <a:srgbClr val="2E7D6A"/>
                 </a:solidFill>
@@ -4348,8 +5232,8 @@
 </p:sld>
 </file>
 
-<file path=ppt/slides/slide6.xml><?xml version="1.0" encoding="utf-8"?>
-<p:sld xmlns:a="http://schemas.openxmlformats.org/drawingml/2006/main" xmlns:p="http://schemas.openxmlformats.org/presentationml/2006/main" xmlns:r="http://schemas.openxmlformats.org/officeDocument/2006/relationships">
+<file path=ppt/slides/slide7.xml><?xml version="1.0" encoding="utf-8"?>
+<p:sld xmlns:a="http://schemas.openxmlformats.org/drawingml/2006/main" xmlns:r="http://schemas.openxmlformats.org/officeDocument/2006/relationships" xmlns:p="http://schemas.openxmlformats.org/presentationml/2006/main">
   <p:cSld>
     <p:bg>
       <p:bgPr>
@@ -4365,7 +5249,14 @@
         <p:cNvGrpSpPr/>
         <p:nvPr/>
       </p:nvGrpSpPr>
-      <p:grpSpPr/>
+      <p:grpSpPr>
+        <a:xfrm>
+          <a:off x="0" y="0"/>
+          <a:ext cx="0" cy="0"/>
+          <a:chOff x="0" y="0"/>
+          <a:chExt cx="0" cy="0"/>
+        </a:xfrm>
+      </p:grpSpPr>
       <p:sp>
         <p:nvSpPr>
           <p:cNvPr id="2" name="TextBox 1"/>
@@ -4389,7 +5280,7 @@
           <a:lstStyle/>
           <a:p>
             <a:pPr>
-              <a:defRPr b="1" sz="3400">
+              <a:defRPr sz="3400" b="1">
                 <a:solidFill>
                   <a:srgbClr val="1F2925"/>
                 </a:solidFill>
@@ -4537,8 +5428,8 @@
 </p:sld>
 </file>
 
-<file path=ppt/slides/slide7.xml><?xml version="1.0" encoding="utf-8"?>
-<p:sld xmlns:a="http://schemas.openxmlformats.org/drawingml/2006/main" xmlns:p="http://schemas.openxmlformats.org/presentationml/2006/main" xmlns:r="http://schemas.openxmlformats.org/officeDocument/2006/relationships">
+<file path=ppt/slides/slide8.xml><?xml version="1.0" encoding="utf-8"?>
+<p:sld xmlns:a="http://schemas.openxmlformats.org/drawingml/2006/main" xmlns:r="http://schemas.openxmlformats.org/officeDocument/2006/relationships" xmlns:p="http://schemas.openxmlformats.org/presentationml/2006/main">
   <p:cSld>
     <p:bg>
       <p:bgPr>
@@ -4554,7 +5445,14 @@
         <p:cNvGrpSpPr/>
         <p:nvPr/>
       </p:nvGrpSpPr>
-      <p:grpSpPr/>
+      <p:grpSpPr>
+        <a:xfrm>
+          <a:off x="0" y="0"/>
+          <a:ext cx="0" cy="0"/>
+          <a:chOff x="0" y="0"/>
+          <a:chExt cx="0" cy="0"/>
+        </a:xfrm>
+      </p:grpSpPr>
       <p:sp>
         <p:nvSpPr>
           <p:cNvPr id="2" name="TextBox 1"/>
@@ -4578,7 +5476,7 @@
           <a:lstStyle/>
           <a:p>
             <a:pPr>
-              <a:defRPr b="1" sz="3400">
+              <a:defRPr sz="3400" b="1">
                 <a:solidFill>
                   <a:srgbClr val="1F2925"/>
                 </a:solidFill>
@@ -4681,8 +5579,8 @@
 </p:sld>
 </file>
 
-<file path=ppt/slides/slide8.xml><?xml version="1.0" encoding="utf-8"?>
-<p:sld xmlns:a="http://schemas.openxmlformats.org/drawingml/2006/main" xmlns:p="http://schemas.openxmlformats.org/presentationml/2006/main" xmlns:r="http://schemas.openxmlformats.org/officeDocument/2006/relationships">
+<file path=ppt/slides/slide9.xml><?xml version="1.0" encoding="utf-8"?>
+<p:sld xmlns:a="http://schemas.openxmlformats.org/drawingml/2006/main" xmlns:r="http://schemas.openxmlformats.org/officeDocument/2006/relationships" xmlns:p="http://schemas.openxmlformats.org/presentationml/2006/main">
   <p:cSld>
     <p:bg>
       <p:bgPr>
@@ -4698,7 +5596,14 @@
         <p:cNvGrpSpPr/>
         <p:nvPr/>
       </p:nvGrpSpPr>
-      <p:grpSpPr/>
+      <p:grpSpPr>
+        <a:xfrm>
+          <a:off x="0" y="0"/>
+          <a:ext cx="0" cy="0"/>
+          <a:chOff x="0" y="0"/>
+          <a:chExt cx="0" cy="0"/>
+        </a:xfrm>
+      </p:grpSpPr>
       <p:sp>
         <p:nvSpPr>
           <p:cNvPr id="2" name="TextBox 1"/>
@@ -4722,7 +5627,7 @@
           <a:lstStyle/>
           <a:p>
             <a:pPr>
-              <a:defRPr b="1" sz="3400">
+              <a:defRPr sz="3400" b="1">
                 <a:solidFill>
                   <a:srgbClr val="1F2925"/>
                 </a:solidFill>
@@ -4828,195 +5733,6 @@
             </a:pPr>
             <a:r>
               <a:t>How GitHub, tests, README, demo video, and PPT complete a project submission.</a:t>
-            </a:r>
-          </a:p>
-        </p:txBody>
-      </p:sp>
-    </p:spTree>
-  </p:cSld>
-  <p:clrMapOvr>
-    <a:masterClrMapping/>
-  </p:clrMapOvr>
-</p:sld>
-</file>
-
-<file path=ppt/slides/slide9.xml><?xml version="1.0" encoding="utf-8"?>
-<p:sld xmlns:a="http://schemas.openxmlformats.org/drawingml/2006/main" xmlns:p="http://schemas.openxmlformats.org/presentationml/2006/main" xmlns:r="http://schemas.openxmlformats.org/officeDocument/2006/relationships">
-  <p:cSld>
-    <p:bg>
-      <p:bgPr>
-        <a:solidFill>
-          <a:srgbClr val="F7F8F5"/>
-        </a:solidFill>
-        <a:effectLst/>
-      </p:bgPr>
-    </p:bg>
-    <p:spTree>
-      <p:nvGrpSpPr>
-        <p:cNvPr id="1" name=""/>
-        <p:cNvGrpSpPr/>
-        <p:nvPr/>
-      </p:nvGrpSpPr>
-      <p:grpSpPr/>
-      <p:sp>
-        <p:nvSpPr>
-          <p:cNvPr id="2" name="TextBox 1"/>
-          <p:cNvSpPr txBox="1"/>
-          <p:nvPr/>
-        </p:nvSpPr>
-        <p:spPr>
-          <a:xfrm>
-            <a:off x="594360" y="411480"/>
-            <a:ext cx="10972800" cy="731520"/>
-          </a:xfrm>
-          <a:prstGeom prst="rect">
-            <a:avLst/>
-          </a:prstGeom>
-          <a:noFill/>
-        </p:spPr>
-        <p:txBody>
-          <a:bodyPr wrap="none">
-            <a:spAutoFit/>
-          </a:bodyPr>
-          <a:lstStyle/>
-          <a:p>
-            <a:pPr>
-              <a:defRPr b="1" sz="3400">
-                <a:solidFill>
-                  <a:srgbClr val="1F2925"/>
-                </a:solidFill>
-              </a:defRPr>
-            </a:pPr>
-            <a:r>
-              <a:t>Demo Checklist</a:t>
-            </a:r>
-          </a:p>
-        </p:txBody>
-      </p:sp>
-      <p:sp>
-        <p:nvSpPr>
-          <p:cNvPr id="3" name="TextBox 2"/>
-          <p:cNvSpPr txBox="1"/>
-          <p:nvPr/>
-        </p:nvSpPr>
-        <p:spPr>
-          <a:xfrm>
-            <a:off x="777240" y="1691640"/>
-            <a:ext cx="10698480" cy="4389120"/>
-          </a:xfrm>
-          <a:prstGeom prst="rect">
-            <a:avLst/>
-          </a:prstGeom>
-          <a:noFill/>
-        </p:spPr>
-        <p:txBody>
-          <a:bodyPr wrap="none">
-            <a:spAutoFit/>
-          </a:bodyPr>
-          <a:lstStyle/>
-          <a:p>
-            <a:pPr>
-              <a:spcAft>
-                <a:spcPts val="1000"/>
-              </a:spcAft>
-              <a:defRPr sz="2000">
-                <a:solidFill>
-                  <a:srgbClr val="1F2925"/>
-                </a:solidFill>
-              </a:defRPr>
-            </a:pPr>
-            <a:r>
-              <a:t>Register using a student email ID.</a:t>
-            </a:r>
-          </a:p>
-          <a:p>
-            <a:pPr>
-              <a:spcAft>
-                <a:spcPts val="1000"/>
-              </a:spcAft>
-              <a:defRPr sz="2000">
-                <a:solidFill>
-                  <a:srgbClr val="1F2925"/>
-                </a:solidFill>
-              </a:defRPr>
-            </a:pPr>
-            <a:r>
-              <a:t>Create a new task.</a:t>
-            </a:r>
-          </a:p>
-          <a:p>
-            <a:pPr>
-              <a:spcAft>
-                <a:spcPts val="1000"/>
-              </a:spcAft>
-              <a:defRPr sz="2000">
-                <a:solidFill>
-                  <a:srgbClr val="1F2925"/>
-                </a:solidFill>
-              </a:defRPr>
-            </a:pPr>
-            <a:r>
-              <a:t>Edit task title or description.</a:t>
-            </a:r>
-          </a:p>
-          <a:p>
-            <a:pPr>
-              <a:spcAft>
-                <a:spcPts val="1000"/>
-              </a:spcAft>
-              <a:defRPr sz="2000">
-                <a:solidFill>
-                  <a:srgbClr val="1F2925"/>
-                </a:solidFill>
-              </a:defRPr>
-            </a:pPr>
-            <a:r>
-              <a:t>Mark the task as completed.</a:t>
-            </a:r>
-          </a:p>
-          <a:p>
-            <a:pPr>
-              <a:spcAft>
-                <a:spcPts val="1000"/>
-              </a:spcAft>
-              <a:defRPr sz="2000">
-                <a:solidFill>
-                  <a:srgbClr val="1F2925"/>
-                </a:solidFill>
-              </a:defRPr>
-            </a:pPr>
-            <a:r>
-              <a:t>Delete the task.</a:t>
-            </a:r>
-          </a:p>
-          <a:p>
-            <a:pPr>
-              <a:spcAft>
-                <a:spcPts val="1000"/>
-              </a:spcAft>
-              <a:defRPr sz="2000">
-                <a:solidFill>
-                  <a:srgbClr val="1F2925"/>
-                </a:solidFill>
-              </a:defRPr>
-            </a:pPr>
-            <a:r>
-              <a:t>Logout securely.</a:t>
-            </a:r>
-          </a:p>
-          <a:p>
-            <a:pPr>
-              <a:spcAft>
-                <a:spcPts val="1000"/>
-              </a:spcAft>
-              <a:defRPr sz="2000">
-                <a:solidFill>
-                  <a:srgbClr val="1F2925"/>
-                </a:solidFill>
-              </a:defRPr>
-            </a:pPr>
-            <a:r>
-              <a:t>Submit YouTube video link, GitHub repository, and this PPT on Taxila.</a:t>
             </a:r>
           </a:p>
         </p:txBody>

</xml_diff>